<commit_message>
docs(presentation): update Attendance Management System slide presentation and report assets
</commit_message>
<xml_diff>
--- a/Attendance_Management_System_Presentation.pptx
+++ b/Attendance_Management_System_Presentation.pptx
@@ -14,6 +14,7 @@
     <p:sldId id="262" r:id="rId13"/>
     <p:sldId id="263" r:id="rId14"/>
     <p:sldId id="264" r:id="rId15"/>
+    <p:sldId id="265" r:id="rId16"/>
   </p:sldIdLst>
   <p:sldSz cx="9144000" cy="6858000" type="screen4x3"/>
   <p:notesSz cx="6858000" cy="9144000"/>
@@ -3089,6 +3090,14 @@
 <file path=ppt/slides/slide1.xml><?xml version="1.0" encoding="utf-8"?>
 <p:sld xmlns:a="http://schemas.openxmlformats.org/drawingml/2006/main" xmlns:p="http://schemas.openxmlformats.org/presentationml/2006/main" xmlns:r="http://schemas.openxmlformats.org/officeDocument/2006/relationships">
   <p:cSld>
+    <p:bg>
+      <p:bgPr>
+        <a:solidFill>
+          <a:srgbClr val="F5F5FA"/>
+        </a:solidFill>
+        <a:effectLst/>
+      </p:bgPr>
+    </p:bg>
     <p:spTree>
       <p:nvGrpSpPr>
         <p:cNvPr id="1" name=""/>
@@ -3112,6 +3121,12 @@
           <a:lstStyle/>
           <a:p>
             <a:r>
+              <a:rPr sz="4000" b="1">
+                <a:solidFill>
+                  <a:srgbClr val="212F3D"/>
+                </a:solidFill>
+                <a:latin typeface="Segoe UI"/>
+              </a:rPr>
               <a:t>Attendance Management System</a:t>
             </a:r>
           </a:p>
@@ -3133,13 +3148,174 @@
           <a:lstStyle/>
           <a:p>
             <a:r>
-              <a:t>A Modern, Role-Based Web Application</a:t>
+              <a:rPr sz="2400">
+                <a:solidFill>
+                  <a:srgbClr val="566573"/>
+                </a:solidFill>
+                <a:latin typeface="Segoe UI"/>
+              </a:rPr>
+              <a:t>A Modern, Cloud-Based Academic Platform</a:t>
             </a:r>
           </a:p>
           <a:p/>
           <a:p>
             <a:r>
-              <a:t>By [Your Name] / [USN]</a:t>
+              <a:rPr sz="2400">
+                <a:solidFill>
+                  <a:srgbClr val="566573"/>
+                </a:solidFill>
+                <a:latin typeface="Segoe UI"/>
+              </a:rPr>
+              <a:t>Developed by:</a:t>
+            </a:r>
+          </a:p>
+          <a:p>
+            <a:r>
+              <a:rPr sz="2400">
+                <a:solidFill>
+                  <a:srgbClr val="566573"/>
+                </a:solidFill>
+                <a:latin typeface="Segoe UI"/>
+              </a:rPr>
+              <a:t>Manas Mishra</a:t>
+            </a:r>
+          </a:p>
+          <a:p>
+            <a:r>
+              <a:rPr sz="2400">
+                <a:solidFill>
+                  <a:srgbClr val="566573"/>
+                </a:solidFill>
+                <a:latin typeface="Segoe UI"/>
+              </a:rPr>
+              <a:t>Malli Akhil</a:t>
+            </a:r>
+          </a:p>
+          <a:p/>
+          <a:p>
+            <a:r>
+              <a:rPr sz="2400">
+                <a:solidFill>
+                  <a:srgbClr val="566573"/>
+                </a:solidFill>
+                <a:latin typeface="Segoe UI"/>
+              </a:rPr>
+              <a:t>Jain (Deemed-to-be University)</a:t>
+            </a:r>
+          </a:p>
+          <a:p/>
+          <a:p>
+            <a:r>
+              <a:rPr sz="2400">
+                <a:solidFill>
+                  <a:srgbClr val="566573"/>
+                </a:solidFill>
+                <a:latin typeface="Segoe UI"/>
+              </a:rPr>
+              <a:t>GitHub: github.com/Ma-nas/Attandance-Managment-system</a:t>
+            </a:r>
+          </a:p>
+        </p:txBody>
+      </p:sp>
+    </p:spTree>
+  </p:cSld>
+  <p:clrMapOvr>
+    <a:masterClrMapping/>
+  </p:clrMapOvr>
+</p:sld>
+</file>
+
+<file path=ppt/slides/slide10.xml><?xml version="1.0" encoding="utf-8"?>
+<p:sld xmlns:a="http://schemas.openxmlformats.org/drawingml/2006/main" xmlns:p="http://schemas.openxmlformats.org/presentationml/2006/main" xmlns:r="http://schemas.openxmlformats.org/officeDocument/2006/relationships">
+  <p:cSld>
+    <p:bg>
+      <p:bgPr>
+        <a:solidFill>
+          <a:srgbClr val="F5F5FA"/>
+        </a:solidFill>
+        <a:effectLst/>
+      </p:bgPr>
+    </p:bg>
+    <p:spTree>
+      <p:nvGrpSpPr>
+        <p:cNvPr id="1" name=""/>
+        <p:cNvGrpSpPr/>
+        <p:nvPr/>
+      </p:nvGrpSpPr>
+      <p:grpSpPr/>
+      <p:sp>
+        <p:nvSpPr>
+          <p:cNvPr id="2" name="Title 1"/>
+          <p:cNvSpPr>
+            <a:spLocks noGrp="1"/>
+          </p:cNvSpPr>
+          <p:nvPr>
+            <p:ph type="ctrTitle"/>
+          </p:nvPr>
+        </p:nvSpPr>
+        <p:spPr/>
+        <p:txBody>
+          <a:bodyPr/>
+          <a:lstStyle/>
+          <a:p>
+            <a:r>
+              <a:rPr sz="4000" b="1">
+                <a:solidFill>
+                  <a:srgbClr val="212F3D"/>
+                </a:solidFill>
+                <a:latin typeface="Segoe UI"/>
+              </a:rPr>
+              <a:t>Conclusion</a:t>
+            </a:r>
+          </a:p>
+        </p:txBody>
+      </p:sp>
+      <p:sp>
+        <p:nvSpPr>
+          <p:cNvPr id="3" name="Subtitle 2"/>
+          <p:cNvSpPr>
+            <a:spLocks noGrp="1"/>
+          </p:cNvSpPr>
+          <p:nvPr>
+            <p:ph type="subTitle" idx="1"/>
+          </p:nvPr>
+        </p:nvSpPr>
+        <p:spPr/>
+        <p:txBody>
+          <a:bodyPr/>
+          <a:lstStyle/>
+          <a:p>
+            <a:r>
+              <a:rPr sz="2400">
+                <a:solidFill>
+                  <a:srgbClr val="566573"/>
+                </a:solidFill>
+                <a:latin typeface="Segoe UI"/>
+              </a:rPr>
+              <a:t>The AMS provides a highly efficient, paperless solution for academic administration.</a:t>
+            </a:r>
+          </a:p>
+          <a:p/>
+          <a:p>
+            <a:r>
+              <a:rPr sz="2400">
+                <a:solidFill>
+                  <a:srgbClr val="566573"/>
+                </a:solidFill>
+                <a:latin typeface="Segoe UI"/>
+              </a:rPr>
+              <a:t>Thank You!</a:t>
+            </a:r>
+          </a:p>
+          <a:p>
+            <a:r>
+              <a:rPr sz="2400">
+                <a:solidFill>
+                  <a:srgbClr val="566573"/>
+                </a:solidFill>
+                <a:latin typeface="Segoe UI"/>
+              </a:rPr>
+              <a:t>Questions?</a:t>
             </a:r>
           </a:p>
         </p:txBody>
@@ -3155,6 +3331,14 @@
 <file path=ppt/slides/slide2.xml><?xml version="1.0" encoding="utf-8"?>
 <p:sld xmlns:a="http://schemas.openxmlformats.org/drawingml/2006/main" xmlns:p="http://schemas.openxmlformats.org/presentationml/2006/main" xmlns:r="http://schemas.openxmlformats.org/officeDocument/2006/relationships">
   <p:cSld>
+    <p:bg>
+      <p:bgPr>
+        <a:solidFill>
+          <a:srgbClr val="F5F5FA"/>
+        </a:solidFill>
+        <a:effectLst/>
+      </p:bgPr>
+    </p:bg>
     <p:spTree>
       <p:nvGrpSpPr>
         <p:cNvPr id="1" name=""/>
@@ -3178,7 +3362,13 @@
           <a:lstStyle/>
           <a:p>
             <a:r>
-              <a:t>1. Problem Statement</a:t>
+              <a:rPr sz="4000" b="1">
+                <a:solidFill>
+                  <a:srgbClr val="212F3D"/>
+                </a:solidFill>
+                <a:latin typeface="Segoe UI"/>
+              </a:rPr>
+              <a:t>1. Introduction &amp; Problem Statement</a:t>
             </a:r>
           </a:p>
         </p:txBody>
@@ -3197,27 +3387,69 @@
         <p:txBody>
           <a:bodyPr/>
           <a:lstStyle/>
-          <a:p>
-            <a:r>
-              <a:t>Traditional attendance methods are manual and paper-based.</a:t>
-            </a:r>
-          </a:p>
-          <a:p>
-            <a:pPr/>
-            <a:r>
-              <a:t>High risk of proxy attendance and human error.</a:t>
-            </a:r>
-          </a:p>
-          <a:p>
-            <a:pPr/>
-            <a:r>
-              <a:t>Time-consuming administrative consolidation.</a:t>
-            </a:r>
-          </a:p>
-          <a:p>
-            <a:pPr/>
-            <a:r>
-              <a:t>Lack of real-time visibility for students and administration.</a:t>
+          <a:p/>
+          <a:p>
+            <a:pPr>
+              <a:spcAft>
+                <a:spcPts val="1400"/>
+              </a:spcAft>
+              <a:defRPr sz="2200">
+                <a:solidFill>
+                  <a:srgbClr val="323232"/>
+                </a:solidFill>
+                <a:latin typeface="Segoe UI"/>
+              </a:defRPr>
+            </a:pPr>
+            <a:r>
+              <a:t>Background: Educational institutions rely heavily on accurate attendance tracking.</a:t>
+            </a:r>
+          </a:p>
+          <a:p>
+            <a:pPr>
+              <a:spcAft>
+                <a:spcPts val="1400"/>
+              </a:spcAft>
+              <a:defRPr sz="2200">
+                <a:solidFill>
+                  <a:srgbClr val="323232"/>
+                </a:solidFill>
+                <a:latin typeface="Segoe UI"/>
+              </a:defRPr>
+            </a:pPr>
+            <a:r>
+              <a:t>Problem: Traditional paper-based methods are time-consuming and error-prone.</a:t>
+            </a:r>
+          </a:p>
+          <a:p>
+            <a:pPr>
+              <a:spcAft>
+                <a:spcPts val="1400"/>
+              </a:spcAft>
+              <a:defRPr sz="2200">
+                <a:solidFill>
+                  <a:srgbClr val="323232"/>
+                </a:solidFill>
+                <a:latin typeface="Segoe UI"/>
+              </a:defRPr>
+            </a:pPr>
+            <a:r>
+              <a:t>Lack of Transparency: Students lack real-time visibility into their attendance.</a:t>
+            </a:r>
+          </a:p>
+          <a:p>
+            <a:pPr>
+              <a:spcAft>
+                <a:spcPts val="1400"/>
+              </a:spcAft>
+              <a:defRPr sz="2200">
+                <a:solidFill>
+                  <a:srgbClr val="323232"/>
+                </a:solidFill>
+                <a:latin typeface="Segoe UI"/>
+              </a:defRPr>
+            </a:pPr>
+            <a:r>
+              <a:t>Administrative Overhead: Consolidating manual records delays interventions.</a:t>
             </a:r>
           </a:p>
         </p:txBody>
@@ -3233,6 +3465,14 @@
 <file path=ppt/slides/slide3.xml><?xml version="1.0" encoding="utf-8"?>
 <p:sld xmlns:a="http://schemas.openxmlformats.org/drawingml/2006/main" xmlns:p="http://schemas.openxmlformats.org/presentationml/2006/main" xmlns:r="http://schemas.openxmlformats.org/officeDocument/2006/relationships">
   <p:cSld>
+    <p:bg>
+      <p:bgPr>
+        <a:solidFill>
+          <a:srgbClr val="F5F5FA"/>
+        </a:solidFill>
+        <a:effectLst/>
+      </p:bgPr>
+    </p:bg>
     <p:spTree>
       <p:nvGrpSpPr>
         <p:cNvPr id="1" name=""/>
@@ -3256,7 +3496,13 @@
           <a:lstStyle/>
           <a:p>
             <a:r>
-              <a:t>2. Proposed Solution</a:t>
+              <a:rPr sz="4000" b="1">
+                <a:solidFill>
+                  <a:srgbClr val="212F3D"/>
+                </a:solidFill>
+                <a:latin typeface="Segoe UI"/>
+              </a:rPr>
+              <a:t>2. Project Objectives</a:t>
             </a:r>
           </a:p>
         </p:txBody>
@@ -3275,27 +3521,69 @@
         <p:txBody>
           <a:bodyPr/>
           <a:lstStyle/>
-          <a:p>
-            <a:r>
-              <a:t>A centralized, cloud-ready web application for real-time tracking.</a:t>
-            </a:r>
-          </a:p>
-          <a:p>
-            <a:pPr/>
-            <a:r>
-              <a:t>Strict Role-Based Access Control (RBAC) for Admins, Trainers, and Students.</a:t>
-            </a:r>
-          </a:p>
-          <a:p>
-            <a:pPr/>
-            <a:r>
-              <a:t>Interactive dashboard for rapid attendance marking by trainers.</a:t>
-            </a:r>
-          </a:p>
-          <a:p>
-            <a:pPr/>
-            <a:r>
-              <a:t>Real-time analytics and transparency for students.</a:t>
+          <a:p/>
+          <a:p>
+            <a:pPr>
+              <a:spcAft>
+                <a:spcPts val="1400"/>
+              </a:spcAft>
+              <a:defRPr sz="2200">
+                <a:solidFill>
+                  <a:srgbClr val="323232"/>
+                </a:solidFill>
+                <a:latin typeface="Segoe UI"/>
+              </a:defRPr>
+            </a:pPr>
+            <a:r>
+              <a:t>Centralized Database: Secure storage for all academic attendance records.</a:t>
+            </a:r>
+          </a:p>
+          <a:p>
+            <a:pPr>
+              <a:spcAft>
+                <a:spcPts val="1400"/>
+              </a:spcAft>
+              <a:defRPr sz="2200">
+                <a:solidFill>
+                  <a:srgbClr val="323232"/>
+                </a:solidFill>
+                <a:latin typeface="Segoe UI"/>
+              </a:defRPr>
+            </a:pPr>
+            <a:r>
+              <a:t>Role-Based Access Control (RBAC): Strict separation of Admin, Trainer, and Student roles.</a:t>
+            </a:r>
+          </a:p>
+          <a:p>
+            <a:pPr>
+              <a:spcAft>
+                <a:spcPts val="1400"/>
+              </a:spcAft>
+              <a:defRPr sz="2200">
+                <a:solidFill>
+                  <a:srgbClr val="323232"/>
+                </a:solidFill>
+                <a:latin typeface="Segoe UI"/>
+              </a:defRPr>
+            </a:pPr>
+            <a:r>
+              <a:t>Real-Time Tracking: Instant visibility for students regarding their academic standing.</a:t>
+            </a:r>
+          </a:p>
+          <a:p>
+            <a:pPr>
+              <a:spcAft>
+                <a:spcPts val="1400"/>
+              </a:spcAft>
+              <a:defRPr sz="2200">
+                <a:solidFill>
+                  <a:srgbClr val="323232"/>
+                </a:solidFill>
+                <a:latin typeface="Segoe UI"/>
+              </a:defRPr>
+            </a:pPr>
+            <a:r>
+              <a:t>Responsive UI: A highly accessible web interface usable on mobile and desktop.</a:t>
             </a:r>
           </a:p>
         </p:txBody>
@@ -3311,6 +3599,14 @@
 <file path=ppt/slides/slide4.xml><?xml version="1.0" encoding="utf-8"?>
 <p:sld xmlns:a="http://schemas.openxmlformats.org/drawingml/2006/main" xmlns:p="http://schemas.openxmlformats.org/presentationml/2006/main" xmlns:r="http://schemas.openxmlformats.org/officeDocument/2006/relationships">
   <p:cSld>
+    <p:bg>
+      <p:bgPr>
+        <a:solidFill>
+          <a:srgbClr val="F5F5FA"/>
+        </a:solidFill>
+        <a:effectLst/>
+      </p:bgPr>
+    </p:bg>
     <p:spTree>
       <p:nvGrpSpPr>
         <p:cNvPr id="1" name=""/>
@@ -3334,7 +3630,13 @@
           <a:lstStyle/>
           <a:p>
             <a:r>
-              <a:t>3. System Architecture &amp; Tech Stack</a:t>
+              <a:rPr sz="4000" b="1">
+                <a:solidFill>
+                  <a:srgbClr val="212F3D"/>
+                </a:solidFill>
+                <a:latin typeface="Segoe UI"/>
+              </a:rPr>
+              <a:t>3. System Architecture</a:t>
             </a:r>
           </a:p>
         </p:txBody>
@@ -3353,33 +3655,85 @@
         <p:txBody>
           <a:bodyPr/>
           <a:lstStyle/>
-          <a:p>
-            <a:r>
-              <a:t>Frontend: React (Vite), TypeScript, Tailwind CSS, TanStack Query.</a:t>
-            </a:r>
-          </a:p>
-          <a:p>
-            <a:pPr/>
-            <a:r>
-              <a:t>Backend: Java 21, Spring Boot (REST APIs), Spring Data JPA.</a:t>
-            </a:r>
-          </a:p>
-          <a:p>
-            <a:pPr/>
-            <a:r>
-              <a:t>Database: PostgreSQL for reliable, relational data storage.</a:t>
-            </a:r>
-          </a:p>
-          <a:p>
-            <a:pPr/>
-            <a:r>
-              <a:t>Security: Spring Security with JWT token-based authentication.</a:t>
-            </a:r>
-          </a:p>
-          <a:p>
-            <a:pPr/>
-            <a:r>
-              <a:t>Architecture: Client-Server with isolated business logic and presentation layers.</a:t>
+          <a:p/>
+          <a:p>
+            <a:pPr>
+              <a:spcAft>
+                <a:spcPts val="1400"/>
+              </a:spcAft>
+              <a:defRPr sz="2200">
+                <a:solidFill>
+                  <a:srgbClr val="323232"/>
+                </a:solidFill>
+                <a:latin typeface="Segoe UI"/>
+              </a:defRPr>
+            </a:pPr>
+            <a:r>
+              <a:t>Client-Server Architecture: Decoupled frontend and backend.</a:t>
+            </a:r>
+          </a:p>
+          <a:p>
+            <a:pPr>
+              <a:spcAft>
+                <a:spcPts val="1400"/>
+              </a:spcAft>
+              <a:defRPr sz="2200">
+                <a:solidFill>
+                  <a:srgbClr val="323232"/>
+                </a:solidFill>
+                <a:latin typeface="Segoe UI"/>
+              </a:defRPr>
+            </a:pPr>
+            <a:r>
+              <a:t>Frontend: React (Vite) with TypeScript and Tailwind CSS.</a:t>
+            </a:r>
+          </a:p>
+          <a:p>
+            <a:pPr>
+              <a:spcAft>
+                <a:spcPts val="1400"/>
+              </a:spcAft>
+              <a:defRPr sz="2200">
+                <a:solidFill>
+                  <a:srgbClr val="323232"/>
+                </a:solidFill>
+                <a:latin typeface="Segoe UI"/>
+              </a:defRPr>
+            </a:pPr>
+            <a:r>
+              <a:t>Backend: Java 21, Spring Boot REST APIs.</a:t>
+            </a:r>
+          </a:p>
+          <a:p>
+            <a:pPr>
+              <a:spcAft>
+                <a:spcPts val="1400"/>
+              </a:spcAft>
+              <a:defRPr sz="2200">
+                <a:solidFill>
+                  <a:srgbClr val="323232"/>
+                </a:solidFill>
+                <a:latin typeface="Segoe UI"/>
+              </a:defRPr>
+            </a:pPr>
+            <a:r>
+              <a:t>Database: PostgreSQL for reliable relational data storage.</a:t>
+            </a:r>
+          </a:p>
+          <a:p>
+            <a:pPr>
+              <a:spcAft>
+                <a:spcPts val="1400"/>
+              </a:spcAft>
+              <a:defRPr sz="2200">
+                <a:solidFill>
+                  <a:srgbClr val="323232"/>
+                </a:solidFill>
+                <a:latin typeface="Segoe UI"/>
+              </a:defRPr>
+            </a:pPr>
+            <a:r>
+              <a:t>Authentication: Secure JWT (JSON Web Token) implementation.</a:t>
             </a:r>
           </a:p>
         </p:txBody>
@@ -3395,6 +3749,14 @@
 <file path=ppt/slides/slide5.xml><?xml version="1.0" encoding="utf-8"?>
 <p:sld xmlns:a="http://schemas.openxmlformats.org/drawingml/2006/main" xmlns:p="http://schemas.openxmlformats.org/presentationml/2006/main" xmlns:r="http://schemas.openxmlformats.org/officeDocument/2006/relationships">
   <p:cSld>
+    <p:bg>
+      <p:bgPr>
+        <a:solidFill>
+          <a:srgbClr val="F5F5FA"/>
+        </a:solidFill>
+        <a:effectLst/>
+      </p:bgPr>
+    </p:bg>
     <p:spTree>
       <p:nvGrpSpPr>
         <p:cNvPr id="1" name=""/>
@@ -3418,14 +3780,154 @@
           <a:lstStyle/>
           <a:p>
             <a:r>
-              <a:t>System Interface: Login Portal</a:t>
+              <a:rPr sz="4000" b="1">
+                <a:solidFill>
+                  <a:srgbClr val="212F3D"/>
+                </a:solidFill>
+                <a:latin typeface="Segoe UI"/>
+              </a:rPr>
+              <a:t>4. Key Features &amp; Modules</a:t>
+            </a:r>
+          </a:p>
+        </p:txBody>
+      </p:sp>
+      <p:sp>
+        <p:nvSpPr>
+          <p:cNvPr id="3" name="Content Placeholder 2"/>
+          <p:cNvSpPr>
+            <a:spLocks noGrp="1"/>
+          </p:cNvSpPr>
+          <p:nvPr>
+            <p:ph idx="1"/>
+          </p:nvPr>
+        </p:nvSpPr>
+        <p:spPr/>
+        <p:txBody>
+          <a:bodyPr/>
+          <a:lstStyle/>
+          <a:p/>
+          <a:p>
+            <a:pPr>
+              <a:spcAft>
+                <a:spcPts val="1400"/>
+              </a:spcAft>
+              <a:defRPr sz="2200">
+                <a:solidFill>
+                  <a:srgbClr val="323232"/>
+                </a:solidFill>
+                <a:latin typeface="Segoe UI"/>
+              </a:defRPr>
+            </a:pPr>
+            <a:r>
+              <a:t>Admin Module: Manage users, departments, subjects, and view global stats.</a:t>
+            </a:r>
+          </a:p>
+          <a:p>
+            <a:pPr>
+              <a:spcAft>
+                <a:spcPts val="1400"/>
+              </a:spcAft>
+              <a:defRPr sz="2200">
+                <a:solidFill>
+                  <a:srgbClr val="323232"/>
+                </a:solidFill>
+                <a:latin typeface="Segoe UI"/>
+              </a:defRPr>
+            </a:pPr>
+            <a:r>
+              <a:t>Trainer Module: Interactive dashboard to instantly mark daily attendance.</a:t>
+            </a:r>
+          </a:p>
+          <a:p>
+            <a:pPr>
+              <a:spcAft>
+                <a:spcPts val="1400"/>
+              </a:spcAft>
+              <a:defRPr sz="2200">
+                <a:solidFill>
+                  <a:srgbClr val="323232"/>
+                </a:solidFill>
+                <a:latin typeface="Segoe UI"/>
+              </a:defRPr>
+            </a:pPr>
+            <a:r>
+              <a:t>Student Module: Personalized view of current attendance percentage and events.</a:t>
+            </a:r>
+          </a:p>
+          <a:p>
+            <a:pPr>
+              <a:spcAft>
+                <a:spcPts val="1400"/>
+              </a:spcAft>
+              <a:defRPr sz="2200">
+                <a:solidFill>
+                  <a:srgbClr val="323232"/>
+                </a:solidFill>
+                <a:latin typeface="Segoe UI"/>
+              </a:defRPr>
+            </a:pPr>
+            <a:r>
+              <a:t>Security: Protected API endpoints and encrypted credentials.</a:t>
+            </a:r>
+          </a:p>
+        </p:txBody>
+      </p:sp>
+    </p:spTree>
+  </p:cSld>
+  <p:clrMapOvr>
+    <a:masterClrMapping/>
+  </p:clrMapOvr>
+</p:sld>
+</file>
+
+<file path=ppt/slides/slide6.xml><?xml version="1.0" encoding="utf-8"?>
+<p:sld xmlns:a="http://schemas.openxmlformats.org/drawingml/2006/main" xmlns:p="http://schemas.openxmlformats.org/presentationml/2006/main" xmlns:r="http://schemas.openxmlformats.org/officeDocument/2006/relationships">
+  <p:cSld>
+    <p:bg>
+      <p:bgPr>
+        <a:solidFill>
+          <a:srgbClr val="F5F5FA"/>
+        </a:solidFill>
+        <a:effectLst/>
+      </p:bgPr>
+    </p:bg>
+    <p:spTree>
+      <p:nvGrpSpPr>
+        <p:cNvPr id="1" name=""/>
+        <p:cNvGrpSpPr/>
+        <p:nvPr/>
+      </p:nvGrpSpPr>
+      <p:grpSpPr/>
+      <p:sp>
+        <p:nvSpPr>
+          <p:cNvPr id="2" name="Title 1"/>
+          <p:cNvSpPr>
+            <a:spLocks noGrp="1"/>
+          </p:cNvSpPr>
+          <p:nvPr>
+            <p:ph type="title"/>
+          </p:nvPr>
+        </p:nvSpPr>
+        <p:spPr/>
+        <p:txBody>
+          <a:bodyPr/>
+          <a:lstStyle/>
+          <a:p>
+            <a:r>
+              <a:rPr sz="4000" b="1">
+                <a:solidFill>
+                  <a:srgbClr val="212F3D"/>
+                </a:solidFill>
+                <a:latin typeface="Segoe UI"/>
+              </a:rPr>
+              <a:t>5. Interface: Secure Login Portal</a:t>
             </a:r>
           </a:p>
         </p:txBody>
       </p:sp>
       <p:pic>
         <p:nvPicPr>
-          <p:cNvPr id="3" name="Picture 2" descr="login.png"/>
+          <p:cNvPr id="3" name="Picture 2" descr="login_page.png"/>
           <p:cNvPicPr>
             <a:picLocks noChangeAspect="1"/>
           </p:cNvPicPr>
@@ -3439,8 +3941,8 @@
         </p:blipFill>
         <p:spPr>
           <a:xfrm>
-            <a:off x="914400" y="1371600"/>
-            <a:ext cx="7315200" cy="4819223"/>
+            <a:off x="914400" y="1645920"/>
+            <a:ext cx="7315200" cy="3569141"/>
           </a:xfrm>
           <a:prstGeom prst="rect">
             <a:avLst/>
@@ -3455,9 +3957,17 @@
 </p:sld>
 </file>
 
-<file path=ppt/slides/slide6.xml><?xml version="1.0" encoding="utf-8"?>
+<file path=ppt/slides/slide7.xml><?xml version="1.0" encoding="utf-8"?>
 <p:sld xmlns:a="http://schemas.openxmlformats.org/drawingml/2006/main" xmlns:p="http://schemas.openxmlformats.org/presentationml/2006/main" xmlns:r="http://schemas.openxmlformats.org/officeDocument/2006/relationships">
   <p:cSld>
+    <p:bg>
+      <p:bgPr>
+        <a:solidFill>
+          <a:srgbClr val="F5F5FA"/>
+        </a:solidFill>
+        <a:effectLst/>
+      </p:bgPr>
+    </p:bg>
     <p:spTree>
       <p:nvGrpSpPr>
         <p:cNvPr id="1" name=""/>
@@ -3481,53 +3991,20 @@
           <a:lstStyle/>
           <a:p>
             <a:r>
-              <a:t>System Interface: Admin Dashboard</a:t>
-            </a:r>
-          </a:p>
-        </p:txBody>
-      </p:sp>
-    </p:spTree>
-  </p:cSld>
-  <p:clrMapOvr>
-    <a:masterClrMapping/>
-  </p:clrMapOvr>
-</p:sld>
-</file>
-
-<file path=ppt/slides/slide7.xml><?xml version="1.0" encoding="utf-8"?>
-<p:sld xmlns:a="http://schemas.openxmlformats.org/drawingml/2006/main" xmlns:p="http://schemas.openxmlformats.org/presentationml/2006/main" xmlns:r="http://schemas.openxmlformats.org/officeDocument/2006/relationships">
-  <p:cSld>
-    <p:spTree>
-      <p:nvGrpSpPr>
-        <p:cNvPr id="1" name=""/>
-        <p:cNvGrpSpPr/>
-        <p:nvPr/>
-      </p:nvGrpSpPr>
-      <p:grpSpPr/>
-      <p:sp>
-        <p:nvSpPr>
-          <p:cNvPr id="2" name="Title 1"/>
-          <p:cNvSpPr>
-            <a:spLocks noGrp="1"/>
-          </p:cNvSpPr>
-          <p:nvPr>
-            <p:ph type="title"/>
-          </p:nvPr>
-        </p:nvSpPr>
-        <p:spPr/>
-        <p:txBody>
-          <a:bodyPr/>
-          <a:lstStyle/>
-          <a:p>
-            <a:r>
-              <a:t>System Interface: Trainer Interface</a:t>
+              <a:rPr sz="4000" b="1">
+                <a:solidFill>
+                  <a:srgbClr val="212F3D"/>
+                </a:solidFill>
+                <a:latin typeface="Segoe UI"/>
+              </a:rPr>
+              <a:t>6. Interface: Admin Center</a:t>
             </a:r>
           </a:p>
         </p:txBody>
       </p:sp>
       <p:pic>
         <p:nvPicPr>
-          <p:cNvPr id="3" name="Picture 2" descr="dashboard.png"/>
+          <p:cNvPr id="3" name="Picture 2" descr="admin_dashboard.png"/>
           <p:cNvPicPr>
             <a:picLocks noChangeAspect="1"/>
           </p:cNvPicPr>
@@ -3541,8 +4018,8 @@
         </p:blipFill>
         <p:spPr>
           <a:xfrm>
-            <a:off x="914400" y="1371600"/>
-            <a:ext cx="7315200" cy="4171950"/>
+            <a:off x="914400" y="1645920"/>
+            <a:ext cx="7315200" cy="3588589"/>
           </a:xfrm>
           <a:prstGeom prst="rect">
             <a:avLst/>
@@ -3560,6 +4037,14 @@
 <file path=ppt/slides/slide8.xml><?xml version="1.0" encoding="utf-8"?>
 <p:sld xmlns:a="http://schemas.openxmlformats.org/drawingml/2006/main" xmlns:p="http://schemas.openxmlformats.org/presentationml/2006/main" xmlns:r="http://schemas.openxmlformats.org/officeDocument/2006/relationships">
   <p:cSld>
+    <p:bg>
+      <p:bgPr>
+        <a:solidFill>
+          <a:srgbClr val="F5F5FA"/>
+        </a:solidFill>
+        <a:effectLst/>
+      </p:bgPr>
+    </p:bg>
     <p:spTree>
       <p:nvGrpSpPr>
         <p:cNvPr id="1" name=""/>
@@ -3583,68 +4068,41 @@
           <a:lstStyle/>
           <a:p>
             <a:r>
-              <a:t>4. Conclusion &amp; Future Scope</a:t>
-            </a:r>
-          </a:p>
-        </p:txBody>
-      </p:sp>
-      <p:sp>
-        <p:nvSpPr>
-          <p:cNvPr id="3" name="Content Placeholder 2"/>
-          <p:cNvSpPr>
-            <a:spLocks noGrp="1"/>
-          </p:cNvSpPr>
-          <p:nvPr>
-            <p:ph idx="1"/>
-          </p:nvPr>
-        </p:nvSpPr>
-        <p:spPr/>
-        <p:txBody>
-          <a:bodyPr/>
-          <a:lstStyle/>
-          <a:p>
-            <a:r>
-              <a:t>Conclusion:</a:t>
-            </a:r>
-          </a:p>
-          <a:p>
-            <a:pPr/>
-            <a:r>
-              <a:t>- Successfully digitized the attendance workflow with a sub-second response rate.</a:t>
-            </a:r>
-          </a:p>
-          <a:p>
-            <a:pPr/>
-            <a:r>
-              <a:t>- Reduced administrative overhead significantly.</a:t>
-            </a:r>
-          </a:p>
-          <a:p>
-            <a:pPr/>
-            <a:r>
-              <a:t>Future Enhancements:</a:t>
-            </a:r>
-          </a:p>
-          <a:p>
-            <a:pPr/>
-            <a:r>
-              <a:t>- Integration with Biometric or RFID scanners.</a:t>
-            </a:r>
-          </a:p>
-          <a:p>
-            <a:pPr/>
-            <a:r>
-              <a:t>- Automated warning emails to parents for low attendance.</a:t>
-            </a:r>
-          </a:p>
-          <a:p>
-            <a:pPr/>
-            <a:r>
-              <a:t>- Machine Learning analytics to predict student dropout rates.</a:t>
-            </a:r>
-          </a:p>
-        </p:txBody>
-      </p:sp>
+              <a:rPr sz="4000" b="1">
+                <a:solidFill>
+                  <a:srgbClr val="212F3D"/>
+                </a:solidFill>
+                <a:latin typeface="Segoe UI"/>
+              </a:rPr>
+              <a:t>7. Interface: Trainer Portal</a:t>
+            </a:r>
+          </a:p>
+        </p:txBody>
+      </p:sp>
+      <p:pic>
+        <p:nvPicPr>
+          <p:cNvPr id="3" name="Picture 2" descr="trainer_dashboard.png"/>
+          <p:cNvPicPr>
+            <a:picLocks noChangeAspect="1"/>
+          </p:cNvPicPr>
+          <p:nvPr/>
+        </p:nvPicPr>
+        <p:blipFill>
+          <a:blip r:embed="rId2"/>
+          <a:stretch>
+            <a:fillRect/>
+          </a:stretch>
+        </p:blipFill>
+        <p:spPr>
+          <a:xfrm>
+            <a:off x="914400" y="1645920"/>
+            <a:ext cx="7315200" cy="3557603"/>
+          </a:xfrm>
+          <a:prstGeom prst="rect">
+            <a:avLst/>
+          </a:prstGeom>
+        </p:spPr>
+      </p:pic>
     </p:spTree>
   </p:cSld>
   <p:clrMapOvr>
@@ -3656,6 +4114,14 @@
 <file path=ppt/slides/slide9.xml><?xml version="1.0" encoding="utf-8"?>
 <p:sld xmlns:a="http://schemas.openxmlformats.org/drawingml/2006/main" xmlns:p="http://schemas.openxmlformats.org/presentationml/2006/main" xmlns:r="http://schemas.openxmlformats.org/officeDocument/2006/relationships">
   <p:cSld>
+    <p:bg>
+      <p:bgPr>
+        <a:solidFill>
+          <a:srgbClr val="F5F5FA"/>
+        </a:solidFill>
+        <a:effectLst/>
+      </p:bgPr>
+    </p:bg>
     <p:spTree>
       <p:nvGrpSpPr>
         <p:cNvPr id="1" name=""/>
@@ -3670,37 +4136,151 @@
             <a:spLocks noGrp="1"/>
           </p:cNvSpPr>
           <p:nvPr>
-            <p:ph type="ctrTitle"/>
-          </p:nvPr>
-        </p:nvSpPr>
-        <p:spPr/>
-        <p:txBody>
-          <a:bodyPr/>
-          <a:lstStyle/>
-          <a:p>
-            <a:r>
-              <a:t>Thank You</a:t>
-            </a:r>
-          </a:p>
-        </p:txBody>
-      </p:sp>
-      <p:sp>
-        <p:nvSpPr>
-          <p:cNvPr id="3" name="Subtitle 2"/>
-          <p:cNvSpPr>
-            <a:spLocks noGrp="1"/>
-          </p:cNvSpPr>
-          <p:nvPr>
-            <p:ph type="subTitle" idx="1"/>
-          </p:nvPr>
-        </p:nvSpPr>
-        <p:spPr/>
-        <p:txBody>
-          <a:bodyPr/>
-          <a:lstStyle/>
-          <a:p>
-            <a:r>
-              <a:t>Questions?</a:t>
+            <p:ph type="title"/>
+          </p:nvPr>
+        </p:nvSpPr>
+        <p:spPr/>
+        <p:txBody>
+          <a:bodyPr/>
+          <a:lstStyle/>
+          <a:p>
+            <a:r>
+              <a:rPr sz="4000" b="1">
+                <a:solidFill>
+                  <a:srgbClr val="212F3D"/>
+                </a:solidFill>
+                <a:latin typeface="Segoe UI"/>
+              </a:rPr>
+              <a:t>8. Results &amp; Future Enhancements</a:t>
+            </a:r>
+          </a:p>
+        </p:txBody>
+      </p:sp>
+      <p:sp>
+        <p:nvSpPr>
+          <p:cNvPr id="3" name="Content Placeholder 2"/>
+          <p:cNvSpPr>
+            <a:spLocks noGrp="1"/>
+          </p:cNvSpPr>
+          <p:nvPr>
+            <p:ph idx="1"/>
+          </p:nvPr>
+        </p:nvSpPr>
+        <p:spPr/>
+        <p:txBody>
+          <a:bodyPr/>
+          <a:lstStyle/>
+          <a:p/>
+          <a:p>
+            <a:pPr>
+              <a:spcAft>
+                <a:spcPts val="1400"/>
+              </a:spcAft>
+              <a:defRPr sz="2200">
+                <a:solidFill>
+                  <a:srgbClr val="323232"/>
+                </a:solidFill>
+                <a:latin typeface="Segoe UI"/>
+              </a:defRPr>
+            </a:pPr>
+            <a:r>
+              <a:t>Results:</a:t>
+            </a:r>
+          </a:p>
+          <a:p>
+            <a:pPr>
+              <a:spcAft>
+                <a:spcPts val="1400"/>
+              </a:spcAft>
+              <a:defRPr sz="2200">
+                <a:solidFill>
+                  <a:srgbClr val="323232"/>
+                </a:solidFill>
+                <a:latin typeface="Segoe UI"/>
+              </a:defRPr>
+            </a:pPr>
+            <a:r>
+              <a:t>- Sub-second response time for attendance submission.</a:t>
+            </a:r>
+          </a:p>
+          <a:p>
+            <a:pPr>
+              <a:spcAft>
+                <a:spcPts val="1400"/>
+              </a:spcAft>
+              <a:defRPr sz="2200">
+                <a:solidFill>
+                  <a:srgbClr val="323232"/>
+                </a:solidFill>
+                <a:latin typeface="Segoe UI"/>
+              </a:defRPr>
+            </a:pPr>
+            <a:r>
+              <a:t>- Complete elimination of manual ledger calculations.</a:t>
+            </a:r>
+          </a:p>
+          <a:p>
+            <a:pPr>
+              <a:spcAft>
+                <a:spcPts val="1400"/>
+              </a:spcAft>
+              <a:defRPr sz="2200">
+                <a:solidFill>
+                  <a:srgbClr val="323232"/>
+                </a:solidFill>
+                <a:latin typeface="Segoe UI"/>
+              </a:defRPr>
+            </a:pPr>
+            <a:r>
+              <a:t>Future Scope:</a:t>
+            </a:r>
+          </a:p>
+          <a:p>
+            <a:pPr>
+              <a:spcAft>
+                <a:spcPts val="1400"/>
+              </a:spcAft>
+              <a:defRPr sz="2200">
+                <a:solidFill>
+                  <a:srgbClr val="323232"/>
+                </a:solidFill>
+                <a:latin typeface="Segoe UI"/>
+              </a:defRPr>
+            </a:pPr>
+            <a:r>
+              <a:t>- Biometric / RFID Scanner Integration.</a:t>
+            </a:r>
+          </a:p>
+          <a:p>
+            <a:pPr>
+              <a:spcAft>
+                <a:spcPts val="1400"/>
+              </a:spcAft>
+              <a:defRPr sz="2200">
+                <a:solidFill>
+                  <a:srgbClr val="323232"/>
+                </a:solidFill>
+                <a:latin typeface="Segoe UI"/>
+              </a:defRPr>
+            </a:pPr>
+            <a:r>
+              <a:t>- Automated warning emails to parents.</a:t>
+            </a:r>
+          </a:p>
+          <a:p>
+            <a:pPr>
+              <a:spcAft>
+                <a:spcPts val="1400"/>
+              </a:spcAft>
+              <a:defRPr sz="2200">
+                <a:solidFill>
+                  <a:srgbClr val="323232"/>
+                </a:solidFill>
+                <a:latin typeface="Segoe UI"/>
+              </a:defRPr>
+            </a:pPr>
+            <a:r>
+              <a:t>- AI/ML analytics to predict and prevent student dropouts.</a:t>
             </a:r>
           </a:p>
         </p:txBody>

</xml_diff>